<commit_message>
rebuild deck and brief around the sourced numbers
</commit_message>
<xml_diff>
--- a/exports/Schwans_Pitch_Deck.pptx
+++ b/exports/Schwans_Pitch_Deck.pptx
@@ -2591,6 +2591,45 @@
         </p:nvSpPr>
         <p:spPr>
           <a:xfrm>
+            <a:off x="685800" y="5989320"/>
+            <a:ext cx="10515600" cy="365760"/>
+          </a:xfrm>
+          <a:prstGeom prst="rect">
+            <a:avLst/>
+          </a:prstGeom>
+          <a:noFill/>
+          <a:ln/>
+        </p:spPr>
+        <p:txBody>
+          <a:bodyPr wrap="square" lIns="0" tIns="0" rIns="0" bIns="0" rtlCol="0" anchor="ctr"/>
+          <a:lstStyle/>
+          <a:p>
+            <a:pPr indent="0" marL="0">
+              <a:buNone/>
+            </a:pPr>
+            <a:r>
+              <a:rPr lang="en-US" sz="1100" dirty="0">
+                <a:solidFill>
+                  <a:srgbClr val="6B7280"/>
+                </a:solidFill>
+                <a:latin typeface="Calibri" pitchFamily="34" charset="0"/>
+                <a:ea typeface="Calibri" pitchFamily="34" charset="-122"/>
+                <a:cs typeface="Calibri" pitchFamily="34" charset="-120"/>
+              </a:rPr>
+              <a:t>Headcount from Schwan's published figures. Deloitte and The Manufacturing Institute put the wider skills gap at 2.1 million unfilled jobs by 2030.</a:t>
+            </a:r>
+            <a:endParaRPr lang="en-US" sz="1100" dirty="0"/>
+          </a:p>
+        </p:txBody>
+      </p:sp>
+      <p:sp>
+        <p:nvSpPr>
+          <p:cNvPr id="7" name="Text 5"/>
+          <p:cNvSpPr txBox="1"/>
+          <p:nvPr/>
+        </p:nvSpPr>
+        <p:spPr>
+          <a:xfrm>
             <a:off x="685800" y="4160520"/>
             <a:ext cx="2468880" cy="822960"/>
           </a:xfrm>
@@ -2616,7 +2655,7 @@
                 <a:ea typeface="Cambria" pitchFamily="34" charset="-122"/>
                 <a:cs typeface="Cambria" pitchFamily="34" charset="-120"/>
               </a:rPr>
-              <a:t>16</a:t>
+              <a:t>8,500</a:t>
             </a:r>
             <a:endParaRPr lang="en-US" sz="5200" dirty="0"/>
           </a:p>
@@ -2624,7 +2663,7 @@
       </p:sp>
       <p:sp>
         <p:nvSpPr>
-          <p:cNvPr id="7" name="Text 5"/>
+          <p:cNvPr id="8" name="Text 6"/>
           <p:cNvSpPr txBox="1"/>
           <p:nvPr/>
         </p:nvSpPr>
@@ -2655,7 +2694,7 @@
                 <a:ea typeface="Calibri" pitchFamily="34" charset="-122"/>
                 <a:cs typeface="Calibri" pitchFamily="34" charset="-120"/>
               </a:rPr>
-              <a:t>plants</a:t>
+              <a:t>employees</a:t>
             </a:r>
             <a:endParaRPr lang="en-US" sz="1400" dirty="0"/>
           </a:p>
@@ -2663,7 +2702,7 @@
       </p:sp>
       <p:sp>
         <p:nvSpPr>
-          <p:cNvPr id="8" name="Text 6"/>
+          <p:cNvPr id="9" name="Text 7"/>
           <p:cNvSpPr txBox="1"/>
           <p:nvPr/>
         </p:nvSpPr>
@@ -2694,7 +2733,7 @@
                 <a:ea typeface="Cambria" pitchFamily="34" charset="-122"/>
                 <a:cs typeface="Cambria" pitchFamily="34" charset="-120"/>
               </a:rPr>
-              <a:t>3</a:t>
+              <a:t>16</a:t>
             </a:r>
             <a:endParaRPr lang="en-US" sz="5200" dirty="0"/>
           </a:p>
@@ -2702,7 +2741,7 @@
       </p:sp>
       <p:sp>
         <p:nvSpPr>
-          <p:cNvPr id="9" name="Text 7"/>
+          <p:cNvPr id="10" name="Text 8"/>
           <p:cNvSpPr txBox="1"/>
           <p:nvPr/>
         </p:nvSpPr>
@@ -2733,7 +2772,7 @@
                 <a:ea typeface="Calibri" pitchFamily="34" charset="-122"/>
                 <a:cs typeface="Calibri" pitchFamily="34" charset="-120"/>
               </a:rPr>
-              <a:t>corporate offices</a:t>
+              <a:t>plants, plus 3 offices</a:t>
             </a:r>
             <a:endParaRPr lang="en-US" sz="1400" dirty="0"/>
           </a:p>
@@ -2741,7 +2780,7 @@
       </p:sp>
       <p:sp>
         <p:nvSpPr>
-          <p:cNvPr id="10" name="Text 8"/>
+          <p:cNvPr id="11" name="Text 9"/>
           <p:cNvSpPr txBox="1"/>
           <p:nvPr/>
         </p:nvSpPr>
@@ -2780,7 +2819,7 @@
       </p:sp>
       <p:sp>
         <p:nvSpPr>
-          <p:cNvPr id="11" name="Text 9"/>
+          <p:cNvPr id="12" name="Text 10"/>
           <p:cNvSpPr txBox="1"/>
           <p:nvPr/>
         </p:nvSpPr>
@@ -2819,7 +2858,7 @@
       </p:sp>
       <p:sp>
         <p:nvSpPr>
-          <p:cNvPr id="12" name="Text 10"/>
+          <p:cNvPr id="13" name="Text 11"/>
           <p:cNvSpPr txBox="1"/>
           <p:nvPr/>
         </p:nvSpPr>
@@ -2858,7 +2897,7 @@
       </p:sp>
       <p:sp>
         <p:nvSpPr>
-          <p:cNvPr id="13" name="Text 11"/>
+          <p:cNvPr id="14" name="Text 12"/>
           <p:cNvSpPr txBox="1"/>
           <p:nvPr/>
         </p:nvSpPr>
@@ -2999,7 +3038,7 @@
                 <a:ea typeface="Calibri" pitchFamily="34" charset="-122"/>
                 <a:cs typeface="Calibri" pitchFamily="34" charset="-120"/>
               </a:rPr>
-              <a:t>Five questions from the challenge. One page each.</a:t>
+              <a:t>The five questions from the challenge, one page each, plus the employee's own view.</a:t>
             </a:r>
             <a:endParaRPr lang="en-US" sz="1500" dirty="0"/>
           </a:p>
@@ -3136,7 +3175,7 @@
                 <a:ea typeface="Calibri" pitchFamily="34" charset="-122"/>
                 <a:cs typeface="Calibri" pitchFamily="34" charset="-120"/>
               </a:rPr>
-              <a:t>A ranked list of what to fix first, plus the biggest gaps today.</a:t>
+              <a:t>A ranked list of what to fix first, plus where coverage is lowest.</a:t>
             </a:r>
             <a:endParaRPr lang="en-US" sz="1450" dirty="0"/>
           </a:p>
@@ -3150,7 +3189,7 @@
         </p:nvSpPr>
         <p:spPr>
           <a:xfrm>
-            <a:off x="685800" y="2734056"/>
+            <a:off x="685800" y="2606040"/>
             <a:ext cx="384048" cy="384048"/>
           </a:xfrm>
           <a:prstGeom prst="ellipse">
@@ -3170,7 +3209,7 @@
         </p:nvSpPr>
         <p:spPr>
           <a:xfrm>
-            <a:off x="685800" y="2734056"/>
+            <a:off x="685800" y="2606040"/>
             <a:ext cx="384048" cy="384048"/>
           </a:xfrm>
           <a:prstGeom prst="rect">
@@ -3209,7 +3248,7 @@
         </p:nvSpPr>
         <p:spPr>
           <a:xfrm>
-            <a:off x="1325880" y="2679192"/>
+            <a:off x="1325880" y="2551176"/>
             <a:ext cx="2834640" cy="365760"/>
           </a:xfrm>
           <a:prstGeom prst="rect">
@@ -3248,7 +3287,7 @@
         </p:nvSpPr>
         <p:spPr>
           <a:xfrm>
-            <a:off x="4251960" y="2697480"/>
+            <a:off x="4251960" y="2569464"/>
             <a:ext cx="6949440" cy="548640"/>
           </a:xfrm>
           <a:prstGeom prst="rect">
@@ -3287,7 +3326,7 @@
         </p:nvSpPr>
         <p:spPr>
           <a:xfrm>
-            <a:off x="685800" y="3630168"/>
+            <a:off x="685800" y="3374136"/>
             <a:ext cx="384048" cy="384048"/>
           </a:xfrm>
           <a:prstGeom prst="ellipse">
@@ -3307,7 +3346,7 @@
         </p:nvSpPr>
         <p:spPr>
           <a:xfrm>
-            <a:off x="685800" y="3630168"/>
+            <a:off x="685800" y="3374136"/>
             <a:ext cx="384048" cy="384048"/>
           </a:xfrm>
           <a:prstGeom prst="rect">
@@ -3346,7 +3385,7 @@
         </p:nvSpPr>
         <p:spPr>
           <a:xfrm>
-            <a:off x="1325880" y="3575304"/>
+            <a:off x="1325880" y="3319272"/>
             <a:ext cx="2834640" cy="365760"/>
           </a:xfrm>
           <a:prstGeom prst="rect">
@@ -3385,7 +3424,7 @@
         </p:nvSpPr>
         <p:spPr>
           <a:xfrm>
-            <a:off x="4251960" y="3593592"/>
+            <a:off x="4251960" y="3337560"/>
             <a:ext cx="6949440" cy="548640"/>
           </a:xfrm>
           <a:prstGeom prst="rect">
@@ -3424,7 +3463,7 @@
         </p:nvSpPr>
         <p:spPr>
           <a:xfrm>
-            <a:off x="685800" y="4526280"/>
+            <a:off x="685800" y="4142232"/>
             <a:ext cx="384048" cy="384048"/>
           </a:xfrm>
           <a:prstGeom prst="ellipse">
@@ -3444,7 +3483,7 @@
         </p:nvSpPr>
         <p:spPr>
           <a:xfrm>
-            <a:off x="685800" y="4526280"/>
+            <a:off x="685800" y="4142232"/>
             <a:ext cx="384048" cy="384048"/>
           </a:xfrm>
           <a:prstGeom prst="rect">
@@ -3483,7 +3522,7 @@
         </p:nvSpPr>
         <p:spPr>
           <a:xfrm>
-            <a:off x="1325880" y="4471416"/>
+            <a:off x="1325880" y="4087368"/>
             <a:ext cx="2834640" cy="365760"/>
           </a:xfrm>
           <a:prstGeom prst="rect">
@@ -3522,7 +3561,7 @@
         </p:nvSpPr>
         <p:spPr>
           <a:xfrm>
-            <a:off x="4251960" y="4489704"/>
+            <a:off x="4251960" y="4105656"/>
             <a:ext cx="6949440" cy="548640"/>
           </a:xfrm>
           <a:prstGeom prst="rect">
@@ -3561,7 +3600,7 @@
         </p:nvSpPr>
         <p:spPr>
           <a:xfrm>
-            <a:off x="685800" y="5422392"/>
+            <a:off x="685800" y="4910328"/>
             <a:ext cx="384048" cy="384048"/>
           </a:xfrm>
           <a:prstGeom prst="ellipse">
@@ -3581,7 +3620,7 @@
         </p:nvSpPr>
         <p:spPr>
           <a:xfrm>
-            <a:off x="685800" y="5422392"/>
+            <a:off x="685800" y="4910328"/>
             <a:ext cx="384048" cy="384048"/>
           </a:xfrm>
           <a:prstGeom prst="rect">
@@ -3620,7 +3659,7 @@
         </p:nvSpPr>
         <p:spPr>
           <a:xfrm>
-            <a:off x="1325880" y="5367528"/>
+            <a:off x="1325880" y="4855464"/>
             <a:ext cx="2834640" cy="365760"/>
           </a:xfrm>
           <a:prstGeom prst="rect">
@@ -3645,6 +3684,143 @@
                 <a:ea typeface="Calibri" pitchFamily="34" charset="-122"/>
                 <a:cs typeface="Calibri" pitchFamily="34" charset="-120"/>
               </a:rPr>
+              <a:t>Employee view</a:t>
+            </a:r>
+            <a:endParaRPr lang="en-US" sz="1700" dirty="0"/>
+          </a:p>
+        </p:txBody>
+      </p:sp>
+      <p:sp>
+        <p:nvSpPr>
+          <p:cNvPr id="23" name="Text 21"/>
+          <p:cNvSpPr txBox="1"/>
+          <p:nvPr/>
+        </p:nvSpPr>
+        <p:spPr>
+          <a:xfrm>
+            <a:off x="4251960" y="4873752"/>
+            <a:ext cx="6949440" cy="548640"/>
+          </a:xfrm>
+          <a:prstGeom prst="rect">
+            <a:avLst/>
+          </a:prstGeom>
+          <a:noFill/>
+          <a:ln/>
+        </p:spPr>
+        <p:txBody>
+          <a:bodyPr wrap="square" lIns="0" tIns="0" rIns="0" bIns="0" rtlCol="0" anchor="ctr"/>
+          <a:lstStyle/>
+          <a:p>
+            <a:pPr indent="0" marL="0">
+              <a:buNone/>
+            </a:pPr>
+            <a:r>
+              <a:rPr lang="en-US" sz="1450" dirty="0">
+                <a:solidFill>
+                  <a:srgbClr val="6B7280"/>
+                </a:solidFill>
+                <a:latin typeface="Calibri" pitchFamily="34" charset="0"/>
+                <a:ea typeface="Calibri" pitchFamily="34" charset="-122"/>
+                <a:cs typeface="Calibri" pitchFamily="34" charset="-120"/>
+              </a:rPr>
+              <a:t>The same data seen by the person: what you know, what only you know, and your next step.</a:t>
+            </a:r>
+            <a:endParaRPr lang="en-US" sz="1450" dirty="0"/>
+          </a:p>
+        </p:txBody>
+      </p:sp>
+      <p:sp>
+        <p:nvSpPr>
+          <p:cNvPr id="24" name="Shape 22"/>
+          <p:cNvSpPr/>
+          <p:nvPr/>
+        </p:nvSpPr>
+        <p:spPr>
+          <a:xfrm>
+            <a:off x="685800" y="5678424"/>
+            <a:ext cx="384048" cy="384048"/>
+          </a:xfrm>
+          <a:prstGeom prst="ellipse">
+            <a:avLst/>
+          </a:prstGeom>
+          <a:solidFill>
+            <a:srgbClr val="8E2B30"/>
+          </a:solidFill>
+          <a:ln/>
+        </p:spPr>
+      </p:sp>
+      <p:sp>
+        <p:nvSpPr>
+          <p:cNvPr id="25" name="Text 23"/>
+          <p:cNvSpPr txBox="1"/>
+          <p:nvPr/>
+        </p:nvSpPr>
+        <p:spPr>
+          <a:xfrm>
+            <a:off x="685800" y="5678424"/>
+            <a:ext cx="384048" cy="384048"/>
+          </a:xfrm>
+          <a:prstGeom prst="rect">
+            <a:avLst/>
+          </a:prstGeom>
+          <a:noFill/>
+          <a:ln/>
+        </p:spPr>
+        <p:txBody>
+          <a:bodyPr wrap="square" lIns="0" tIns="0" rIns="0" bIns="0" rtlCol="0" anchor="ctr"/>
+          <a:lstStyle/>
+          <a:p>
+            <a:pPr algn="ctr" indent="0" marL="0">
+              <a:buNone/>
+            </a:pPr>
+            <a:r>
+              <a:rPr lang="en-US" sz="1500" b="1" dirty="0">
+                <a:solidFill>
+                  <a:srgbClr val="FFFFFF"/>
+                </a:solidFill>
+                <a:latin typeface="Calibri" pitchFamily="34" charset="0"/>
+                <a:ea typeface="Calibri" pitchFamily="34" charset="-122"/>
+                <a:cs typeface="Calibri" pitchFamily="34" charset="-120"/>
+              </a:rPr>
+              <a:t>6</a:t>
+            </a:r>
+            <a:endParaRPr lang="en-US" sz="1500" dirty="0"/>
+          </a:p>
+        </p:txBody>
+      </p:sp>
+      <p:sp>
+        <p:nvSpPr>
+          <p:cNvPr id="26" name="Text 24"/>
+          <p:cNvSpPr txBox="1"/>
+          <p:nvPr/>
+        </p:nvSpPr>
+        <p:spPr>
+          <a:xfrm>
+            <a:off x="1325880" y="5623560"/>
+            <a:ext cx="2834640" cy="365760"/>
+          </a:xfrm>
+          <a:prstGeom prst="rect">
+            <a:avLst/>
+          </a:prstGeom>
+          <a:noFill/>
+          <a:ln/>
+        </p:spPr>
+        <p:txBody>
+          <a:bodyPr wrap="square" lIns="0" tIns="0" rIns="0" bIns="0" rtlCol="0" anchor="ctr"/>
+          <a:lstStyle/>
+          <a:p>
+            <a:pPr indent="0" marL="0">
+              <a:buNone/>
+            </a:pPr>
+            <a:r>
+              <a:rPr lang="en-US" sz="1700" b="1" dirty="0">
+                <a:solidFill>
+                  <a:srgbClr val="15181D"/>
+                </a:solidFill>
+                <a:latin typeface="Calibri" pitchFamily="34" charset="0"/>
+                <a:ea typeface="Calibri" pitchFamily="34" charset="-122"/>
+                <a:cs typeface="Calibri" pitchFamily="34" charset="-120"/>
+              </a:rPr>
               <a:t>Plants and offices</a:t>
             </a:r>
             <a:endParaRPr lang="en-US" sz="1700" dirty="0"/>
@@ -3653,13 +3829,13 @@
       </p:sp>
       <p:sp>
         <p:nvSpPr>
-          <p:cNvPr id="23" name="Text 21"/>
-          <p:cNvSpPr txBox="1"/>
-          <p:nvPr/>
-        </p:nvSpPr>
-        <p:spPr>
-          <a:xfrm>
-            <a:off x="4251960" y="5385816"/>
+          <p:cNvPr id="27" name="Text 25"/>
+          <p:cNvSpPr txBox="1"/>
+          <p:nvPr/>
+        </p:nvSpPr>
+        <p:spPr>
+          <a:xfrm>
+            <a:off x="4251960" y="5641848"/>
             <a:ext cx="6949440" cy="548640"/>
           </a:xfrm>
           <a:prstGeom prst="rect">
@@ -6468,7 +6644,7 @@
                 <a:ea typeface="Calibri" pitchFamily="34" charset="-122"/>
                 <a:cs typeface="Calibri" pitchFamily="34" charset="-120"/>
               </a:rPr>
-              <a:t>Real HR data instead of demo numbers.</a:t>
+              <a:t>Connect to the HR system so the numbers are live instead of seeded.</a:t>
             </a:r>
             <a:endParaRPr lang="en-US" sz="1700" dirty="0"/>
           </a:p>
@@ -6508,7 +6684,7 @@
                 <a:ea typeface="Calibri" pitchFamily="34" charset="-122"/>
                 <a:cs typeface="Calibri" pitchFamily="34" charset="-120"/>
               </a:rPr>
-              <a:t>An employee view, so a person sees their own plan.</a:t>
+              <a:t>Match people to plans automatically, instead of one written step per skill.</a:t>
             </a:r>
             <a:endParaRPr lang="en-US" sz="1700" dirty="0"/>
           </a:p>

</xml_diff>

<commit_message>
rebuild deck, brief and screenshots after the fact check
</commit_message>
<xml_diff>
--- a/exports/Schwans_Pitch_Deck.pptx
+++ b/exports/Schwans_Pitch_Deck.pptx
@@ -1228,7 +1228,7 @@
           <a:p>
             <a:r>
               <a:rPr lang="en-US" dirty="0"/>
-              <a:t>Schwan's has 16 plants, 3 offices and 4 job groups. What it does not have is one place that shows what its people can do.</a:t>
+              <a:t>More than a dozen US plants, four job groups, and a new plant opening in 2027. What the company does not have is one place that shows what its people can do.</a:t>
             </a:r>
             <a:endParaRPr lang="en-US" dirty="0"/>
           </a:p>
@@ -1668,7 +1668,7 @@
           <a:p>
             <a:r>
               <a:rPr lang="en-US" dirty="0"/>
-              <a:t>Sioux Falls needs automation techs before it opens. We are at 34 percent and need 65.</a:t>
+              <a:t>Sioux Falls, 700,000 square feet of Asian-style food production, needs automation techs before it opens in 2027. We are at 34 percent and need 65.</a:t>
             </a:r>
             <a:endParaRPr lang="en-US" dirty="0"/>
           </a:p>
@@ -2616,7 +2616,7 @@
                 <a:ea typeface="Calibri" pitchFamily="34" charset="-122"/>
                 <a:cs typeface="Calibri" pitchFamily="34" charset="-120"/>
               </a:rPr>
-              <a:t>Headcount from Schwan's published figures. Deloitte and The Manufacturing Institute put the wider skills gap at 2.1 million unfilled jobs by 2030.</a:t>
+              <a:t>Facility count and job groups from Schwan's own careers site. Deloitte and The Manufacturing Institute put the wider skills gap at 2.1 million unfilled jobs by 2030. Every source is listed in the app and in FACTS.md.</a:t>
             </a:r>
             <a:endParaRPr lang="en-US" sz="1100" dirty="0"/>
           </a:p>
@@ -2655,7 +2655,7 @@
                 <a:ea typeface="Cambria" pitchFamily="34" charset="-122"/>
                 <a:cs typeface="Cambria" pitchFamily="34" charset="-120"/>
               </a:rPr>
-              <a:t>8,500</a:t>
+              <a:t>12+</a:t>
             </a:r>
             <a:endParaRPr lang="en-US" sz="5200" dirty="0"/>
           </a:p>
@@ -2694,7 +2694,7 @@
                 <a:ea typeface="Calibri" pitchFamily="34" charset="-122"/>
                 <a:cs typeface="Calibri" pitchFamily="34" charset="-120"/>
               </a:rPr>
-              <a:t>employees</a:t>
+              <a:t>US facilities</a:t>
             </a:r>
             <a:endParaRPr lang="en-US" sz="1400" dirty="0"/>
           </a:p>
@@ -2733,7 +2733,7 @@
                 <a:ea typeface="Cambria" pitchFamily="34" charset="-122"/>
                 <a:cs typeface="Cambria" pitchFamily="34" charset="-120"/>
               </a:rPr>
-              <a:t>16</a:t>
+              <a:t>4</a:t>
             </a:r>
             <a:endParaRPr lang="en-US" sz="5200" dirty="0"/>
           </a:p>
@@ -2772,7 +2772,7 @@
                 <a:ea typeface="Calibri" pitchFamily="34" charset="-122"/>
                 <a:cs typeface="Calibri" pitchFamily="34" charset="-120"/>
               </a:rPr>
-              <a:t>plants, plus 3 offices</a:t>
+              <a:t>job groups</a:t>
             </a:r>
             <a:endParaRPr lang="en-US" sz="1400" dirty="0"/>
           </a:p>
@@ -2811,7 +2811,7 @@
                 <a:ea typeface="Cambria" pitchFamily="34" charset="-122"/>
                 <a:cs typeface="Cambria" pitchFamily="34" charset="-120"/>
               </a:rPr>
-              <a:t>4</a:t>
+              <a:t>2027</a:t>
             </a:r>
             <a:endParaRPr lang="en-US" sz="5200" dirty="0"/>
           </a:p>
@@ -2850,7 +2850,7 @@
                 <a:ea typeface="Calibri" pitchFamily="34" charset="-122"/>
                 <a:cs typeface="Calibri" pitchFamily="34" charset="-120"/>
               </a:rPr>
-              <a:t>job groups</a:t>
+              <a:t>Sioux Falls opens</a:t>
             </a:r>
             <a:endParaRPr lang="en-US" sz="1400" dirty="0"/>
           </a:p>
@@ -6044,7 +6044,7 @@
                 <a:ea typeface="Calibri" pitchFamily="34" charset="-122"/>
                 <a:cs typeface="Calibri" pitchFamily="34" charset="-120"/>
               </a:rPr>
-              <a:t>Tied to things Schwan's is actually doing: the Sioux Falls plant, demand forecasting, the CJ integration.</a:t>
+              <a:t>Tied to things Schwan's is actually doing: the Sioux Falls plant opening in 2027, demand forecasting, the CJ integration.</a:t>
             </a:r>
             <a:endParaRPr lang="en-US" sz="1500" dirty="0"/>
           </a:p>

</xml_diff>